<commit_message>
Three rules for the costs that dominate data lakes: BQ-006, BQ-007 and GCS-001
BQ-006 flags a small table used as a high-frequency state store, where slot time is
lock waiting and not scanning. BQ-007 flags a large table recreated in full on every
run. GCS-001 flags a prefix that gains objects every day with no lifecycle rule.

The adapters read the two new BigQuery datasets from JOBS_BY_PROJECT joined to
TABLE_STORAGE, and Cloud Storage prefixes from an approved Storage Insights dataset
(read-only, dataset-scoped, checked by preflight and the query guard). The guard now
ignores write keywords inside string literals. Synthetic scenarios, golden files,
release evidence and docs are regenerated: 14 findings from 12 rules, 135 tests.
Adds scripts/pruning_dry_run.py, which measures partition pruning by dry run.
</commit_message>
<xml_diff>
--- a/docs/evidence/release-fixture/synthetic-finops-assessment.pptx
+++ b/docs/evidence/release-fixture/synthetic-finops-assessment.pptx
@@ -12,6 +12,8 @@
     <p:sldId id="260" r:id="rId11"/>
     <p:sldId id="261" r:id="rId12"/>
     <p:sldId id="262" r:id="rId13"/>
+    <p:sldId id="263" r:id="rId14"/>
+    <p:sldId id="264" r:id="rId15"/>
   </p:sldIdLst>
   <p:sldSz cx="12191695" cy="6858000" type="screen4x3"/>
   <p:notesSz cx="6858000" cy="9144000"/>
@@ -3343,7 +3345,7 @@
       </p:sp>
       <p:sp>
         <p:nvSpPr>
-          <p:cNvPr id="4" name="Tile Findings" descr="Findings: 11"/>
+          <p:cNvPr id="4" name="Tile Findings" descr="Findings: 14"/>
           <p:cNvSpPr/>
           <p:nvPr/>
         </p:nvSpPr>
@@ -3463,7 +3465,7 @@
                 </a:solidFill>
                 <a:latin typeface="Calibri"/>
               </a:rPr>
-              <a:t>11</a:t>
+              <a:t>14</a:t>
             </a:r>
           </a:p>
           <a:p>
@@ -3486,7 +3488,7 @@
       </p:sp>
       <p:sp>
         <p:nvSpPr>
-          <p:cNvPr id="7" name="Tile High" descr="High: 5"/>
+          <p:cNvPr id="7" name="Tile High" descr="High: 7"/>
           <p:cNvSpPr/>
           <p:nvPr/>
         </p:nvSpPr>
@@ -3606,7 +3608,7 @@
                 </a:solidFill>
                 <a:latin typeface="Calibri"/>
               </a:rPr>
-              <a:t>5</a:t>
+              <a:t>7</a:t>
             </a:r>
           </a:p>
           <a:p>
@@ -3629,7 +3631,7 @@
       </p:sp>
       <p:sp>
         <p:nvSpPr>
-          <p:cNvPr id="10" name="Tile Medium" descr="Medium: 4"/>
+          <p:cNvPr id="10" name="Tile Medium" descr="Medium: 5"/>
           <p:cNvSpPr/>
           <p:nvPr/>
         </p:nvSpPr>
@@ -3749,7 +3751,7 @@
                 </a:solidFill>
                 <a:latin typeface="Calibri"/>
               </a:rPr>
-              <a:t>4</a:t>
+              <a:t>5</a:t>
             </a:r>
           </a:p>
           <a:p>
@@ -3947,7 +3949,7 @@
                 </a:solidFill>
                 <a:latin typeface="Calibri"/>
               </a:rPr>
-              <a:t>GCP: 6 findings. The largest job billed 3.0 TB without partition pruning.</a:t>
+              <a:t>GCP: 9 findings. The largest job billed 3.0 TB without partition pruning.</a:t>
             </a:r>
           </a:p>
           <a:p>
@@ -3979,7 +3981,7 @@
                 </a:solidFill>
                 <a:latin typeface="Calibri"/>
               </a:rPr>
-              <a:t>4 of 11 findings carry an upper-bound estimate in TB, slot-hours, or USD; none is a saving.</a:t>
+              <a:t>7 of 14 findings carry an upper-bound estimate in TB, slot-hours, or USD; none is a saving.</a:t>
             </a:r>
           </a:p>
           <a:p>
@@ -5796,7 +5798,7 @@
                 </a:solidFill>
                 <a:latin typeface="Calibri"/>
               </a:rPr>
-              <a:t>Prioritized recommendations</a:t>
+              <a:t>Prioritized recommendations (1 of 2)</a:t>
             </a:r>
           </a:p>
         </p:txBody>
@@ -6710,7 +6712,7 @@
                           </a:solidFill>
                           <a:latin typeface="Calibri"/>
                         </a:rPr>
-                        <a:t>medium</a:t>
+                        <a:t>high</a:t>
                       </a:r>
                     </a:p>
                   </a:txBody>
@@ -6732,7 +6734,7 @@
                           </a:solidFill>
                           <a:latin typeface="Calibri"/>
                         </a:rPr>
-                        <a:t>AWS-002</a:t>
+                        <a:t>BQ-006</a:t>
                       </a:r>
                     </a:p>
                   </a:txBody>
@@ -6754,7 +6756,7 @@
                           </a:solidFill>
                           <a:latin typeface="Calibri"/>
                         </a:rPr>
-                        <a:t>team=(untagged)</a:t>
+                        <a:t>ops.rate_control</a:t>
                       </a:r>
                     </a:p>
                   </a:txBody>
@@ -6776,7 +6778,7 @@
                           </a:solidFill>
                           <a:latin typeface="Calibri"/>
                         </a:rPr>
-                        <a:t>Attribute untagged spend to an owner</a:t>
+                        <a:t>Move high-frequency state out of BigQuery</a:t>
                       </a:r>
                     </a:p>
                   </a:txBody>
@@ -6798,7 +6800,7 @@
                           </a:solidFill>
                           <a:latin typeface="Calibri"/>
                         </a:rPr>
-                        <a:t>medium</a:t>
+                        <a:t>high</a:t>
                       </a:r>
                     </a:p>
                   </a:txBody>
@@ -6844,7 +6846,7 @@
                           </a:solidFill>
                           <a:latin typeface="Calibri"/>
                         </a:rPr>
-                        <a:t>medium</a:t>
+                        <a:t>high</a:t>
                       </a:r>
                     </a:p>
                   </a:txBody>
@@ -6866,7 +6868,7 @@
                           </a:solidFill>
                           <a:latin typeface="Calibri"/>
                         </a:rPr>
-                        <a:t>BQ-002</a:t>
+                        <a:t>BQ-007</a:t>
                       </a:r>
                     </a:p>
                   </a:txBody>
@@ -6888,7 +6890,7 @@
                           </a:solidFill>
                           <a:latin typeface="Calibri"/>
                         </a:rPr>
-                        <a:t>fp-adhoc-cohort</a:t>
+                        <a:t>trusted.reports</a:t>
                       </a:r>
                     </a:p>
                   </a:txBody>
@@ -6910,7 +6912,7 @@
                           </a:solidFill>
                           <a:latin typeface="Calibri"/>
                         </a:rPr>
-                        <a:t>Evaluate materializing or caching the repeated query</a:t>
+                        <a:t>Rebuild only changed partitions</a:t>
                       </a:r>
                     </a:p>
                   </a:txBody>
@@ -7000,7 +7002,7 @@
                           </a:solidFill>
                           <a:latin typeface="Calibri"/>
                         </a:rPr>
-                        <a:t>BQ-004</a:t>
+                        <a:t>AWS-002</a:t>
                       </a:r>
                     </a:p>
                   </a:txBody>
@@ -7022,7 +7024,7 @@
                           </a:solidFill>
                           <a:latin typeface="Calibri"/>
                         </a:rPr>
-                        <a:t>fp-hourly-kpi-refresh</a:t>
+                        <a:t>team=(untagged)</a:t>
                       </a:r>
                     </a:p>
                   </a:txBody>
@@ -7044,7 +7046,7 @@
                           </a:solidFill>
                           <a:latin typeface="Calibri"/>
                         </a:rPr>
-                        <a:t>Align schedule frequency with source refreshes</a:t>
+                        <a:t>Attribute untagged spend to an owner</a:t>
                       </a:r>
                     </a:p>
                   </a:txBody>
@@ -7134,7 +7136,7 @@
                           </a:solidFill>
                           <a:latin typeface="Calibri"/>
                         </a:rPr>
-                        <a:t>BQ-005</a:t>
+                        <a:t>BQ-002</a:t>
                       </a:r>
                     </a:p>
                   </a:txBody>
@@ -7156,7 +7158,7 @@
                           </a:solidFill>
                           <a:latin typeface="Calibri"/>
                         </a:rPr>
-                        <a:t>res-batch-etl</a:t>
+                        <a:t>fp-adhoc-cohort</a:t>
                       </a:r>
                     </a:p>
                   </a:txBody>
@@ -7178,7 +7180,7 @@
                           </a:solidFill>
                           <a:latin typeface="Calibri"/>
                         </a:rPr>
-                        <a:t>Review reservation baseline against peak usage</a:t>
+                        <a:t>Evaluate materializing or caching the repeated query</a:t>
                       </a:r>
                     </a:p>
                   </a:txBody>
@@ -7246,7 +7248,7 @@
                           </a:solidFill>
                           <a:latin typeface="Calibri"/>
                         </a:rPr>
-                        <a:t>low</a:t>
+                        <a:t>medium</a:t>
                       </a:r>
                     </a:p>
                   </a:txBody>
@@ -7268,7 +7270,7 @@
                           </a:solidFill>
                           <a:latin typeface="Calibri"/>
                         </a:rPr>
-                        <a:t>AWS-003</a:t>
+                        <a:t>BQ-004</a:t>
                       </a:r>
                     </a:p>
                   </a:txBody>
@@ -7290,7 +7292,7 @@
                           </a:solidFill>
                           <a:latin typeface="Calibri"/>
                         </a:rPr>
-                        <a:t>redshift-reporting</a:t>
+                        <a:t>fp-hourly-kpi-refresh</a:t>
                       </a:r>
                     </a:p>
                   </a:txBody>
@@ -7312,7 +7314,7 @@
                           </a:solidFill>
                           <a:latin typeface="Calibri"/>
                         </a:rPr>
-                        <a:t>Confirm owner and dependencies before resizing</a:t>
+                        <a:t>Align schedule frequency with source refreshes</a:t>
                       </a:r>
                     </a:p>
                   </a:txBody>
@@ -7334,7 +7336,7 @@
                           </a:solidFill>
                           <a:latin typeface="Calibri"/>
                         </a:rPr>
-                        <a:t>low</a:t>
+                        <a:t>medium</a:t>
                       </a:r>
                     </a:p>
                   </a:txBody>
@@ -7380,7 +7382,7 @@
                           </a:solidFill>
                           <a:latin typeface="Calibri"/>
                         </a:rPr>
-                        <a:t>low</a:t>
+                        <a:t>medium</a:t>
                       </a:r>
                     </a:p>
                   </a:txBody>
@@ -7402,7 +7404,7 @@
                           </a:solidFill>
                           <a:latin typeface="Calibri"/>
                         </a:rPr>
-                        <a:t>CMT-001</a:t>
+                        <a:t>BQ-005</a:t>
                       </a:r>
                     </a:p>
                   </a:txBody>
@@ -7424,7 +7426,7 @@
                           </a:solidFill>
                           <a:latin typeface="Calibri"/>
                         </a:rPr>
-                        <a:t>AWS Glue</a:t>
+                        <a:t>res-batch-etl</a:t>
                       </a:r>
                     </a:p>
                   </a:txBody>
@@ -7446,7 +7448,7 @@
                           </a:solidFill>
                           <a:latin typeface="Calibri"/>
                         </a:rPr>
-                        <a:t>Collect missing evidence before any commitment</a:t>
+                        <a:t>Review reservation baseline against peak usage</a:t>
                       </a:r>
                     </a:p>
                   </a:txBody>
@@ -7532,7 +7534,7 @@
 
 <file path=ppt/slides/slide5.xml><?xml version="1.0" encoding="utf-8"?>
 <p:sld xmlns:a="http://schemas.openxmlformats.org/drawingml/2006/main" xmlns:p="http://schemas.openxmlformats.org/presentationml/2006/main" xmlns:r="http://schemas.openxmlformats.org/officeDocument/2006/relationships">
-  <p:cSld name="risks-and-assumptions">
+  <p:cSld name="prioritized-recommendations">
     <p:bg>
       <p:bgPr>
         <a:solidFill>
@@ -7578,7 +7580,7 @@
                 </a:solidFill>
                 <a:latin typeface="Calibri"/>
               </a:rPr>
-              <a:t>Risks and assumptions</a:t>
+              <a:t>Prioritized recommendations (2 of 2)</a:t>
             </a:r>
           </a:p>
         </p:txBody>
@@ -7627,6 +7629,716 @@
           </a:p>
         </p:txBody>
       </p:sp>
+      <p:graphicFrame>
+        <p:nvGraphicFramePr>
+          <p:cNvPr id="4" name="Table"/>
+          <p:cNvGraphicFramePr>
+            <a:graphicFrameLocks noGrp="1"/>
+          </p:cNvGraphicFramePr>
+          <p:nvPr/>
+        </p:nvGraphicFramePr>
+        <p:xfrm>
+          <a:off x="548640" y="1325880"/>
+          <a:ext cx="11064240" cy="1536192"/>
+        </p:xfrm>
+        <a:graphic>
+          <a:graphicData uri="http://schemas.openxmlformats.org/drawingml/2006/table">
+            <a:tbl>
+              <a:tblPr firstRow="1" bandRow="1">
+                <a:tableStyleId>{5C22544A-7EE6-4342-B048-85BDC9FD1C3A}</a:tableStyleId>
+              </a:tblPr>
+              <a:tblGrid>
+                <a:gridCol w="457200"/>
+                <a:gridCol w="914400"/>
+                <a:gridCol w="914400"/>
+                <a:gridCol w="2743200"/>
+                <a:gridCol w="4754880"/>
+                <a:gridCol w="1280160"/>
+              </a:tblGrid>
+              <a:tr h="384048">
+                <a:tc>
+                  <a:txBody>
+                    <a:bodyPr wrap="square"/>
+                    <a:lstStyle/>
+                    <a:p>
+                      <a:r>
+                        <a:rPr sz="1200" b="1">
+                          <a:solidFill>
+                            <a:srgbClr val="FFFFFF"/>
+                          </a:solidFill>
+                          <a:latin typeface="Calibri"/>
+                        </a:rPr>
+                        <a:t>#</a:t>
+                      </a:r>
+                    </a:p>
+                  </a:txBody>
+                  <a:tcPr marL="73152" marR="73152" marT="36576" marB="36576" anchor="ctr">
+                    <a:solidFill>
+                      <a:srgbClr val="0F172A"/>
+                    </a:solidFill>
+                  </a:tcPr>
+                </a:tc>
+                <a:tc>
+                  <a:txBody>
+                    <a:bodyPr wrap="square"/>
+                    <a:lstStyle/>
+                    <a:p>
+                      <a:r>
+                        <a:rPr sz="1200" b="1">
+                          <a:solidFill>
+                            <a:srgbClr val="FFFFFF"/>
+                          </a:solidFill>
+                          <a:latin typeface="Calibri"/>
+                        </a:rPr>
+                        <a:t>Priority</a:t>
+                      </a:r>
+                    </a:p>
+                  </a:txBody>
+                  <a:tcPr marL="73152" marR="73152" marT="36576" marB="36576" anchor="ctr">
+                    <a:solidFill>
+                      <a:srgbClr val="0F172A"/>
+                    </a:solidFill>
+                  </a:tcPr>
+                </a:tc>
+                <a:tc>
+                  <a:txBody>
+                    <a:bodyPr wrap="square"/>
+                    <a:lstStyle/>
+                    <a:p>
+                      <a:r>
+                        <a:rPr sz="1200" b="1">
+                          <a:solidFill>
+                            <a:srgbClr val="FFFFFF"/>
+                          </a:solidFill>
+                          <a:latin typeface="Calibri"/>
+                        </a:rPr>
+                        <a:t>Rule</a:t>
+                      </a:r>
+                    </a:p>
+                  </a:txBody>
+                  <a:tcPr marL="73152" marR="73152" marT="36576" marB="36576" anchor="ctr">
+                    <a:solidFill>
+                      <a:srgbClr val="0F172A"/>
+                    </a:solidFill>
+                  </a:tcPr>
+                </a:tc>
+                <a:tc>
+                  <a:txBody>
+                    <a:bodyPr wrap="square"/>
+                    <a:lstStyle/>
+                    <a:p>
+                      <a:r>
+                        <a:rPr sz="1200" b="1">
+                          <a:solidFill>
+                            <a:srgbClr val="FFFFFF"/>
+                          </a:solidFill>
+                          <a:latin typeface="Calibri"/>
+                        </a:rPr>
+                        <a:t>Subject</a:t>
+                      </a:r>
+                    </a:p>
+                  </a:txBody>
+                  <a:tcPr marL="73152" marR="73152" marT="36576" marB="36576" anchor="ctr">
+                    <a:solidFill>
+                      <a:srgbClr val="0F172A"/>
+                    </a:solidFill>
+                  </a:tcPr>
+                </a:tc>
+                <a:tc>
+                  <a:txBody>
+                    <a:bodyPr wrap="square"/>
+                    <a:lstStyle/>
+                    <a:p>
+                      <a:r>
+                        <a:rPr sz="1200" b="1">
+                          <a:solidFill>
+                            <a:srgbClr val="FFFFFF"/>
+                          </a:solidFill>
+                          <a:latin typeface="Calibri"/>
+                        </a:rPr>
+                        <a:t>Next action</a:t>
+                      </a:r>
+                    </a:p>
+                  </a:txBody>
+                  <a:tcPr marL="73152" marR="73152" marT="36576" marB="36576" anchor="ctr">
+                    <a:solidFill>
+                      <a:srgbClr val="0F172A"/>
+                    </a:solidFill>
+                  </a:tcPr>
+                </a:tc>
+                <a:tc>
+                  <a:txBody>
+                    <a:bodyPr wrap="square"/>
+                    <a:lstStyle/>
+                    <a:p>
+                      <a:r>
+                        <a:rPr sz="1200" b="1">
+                          <a:solidFill>
+                            <a:srgbClr val="FFFFFF"/>
+                          </a:solidFill>
+                          <a:latin typeface="Calibri"/>
+                        </a:rPr>
+                        <a:t>Confidence</a:t>
+                      </a:r>
+                    </a:p>
+                  </a:txBody>
+                  <a:tcPr marL="73152" marR="73152" marT="36576" marB="36576" anchor="ctr">
+                    <a:solidFill>
+                      <a:srgbClr val="0F172A"/>
+                    </a:solidFill>
+                  </a:tcPr>
+                </a:tc>
+              </a:tr>
+              <a:tr h="384048">
+                <a:tc>
+                  <a:txBody>
+                    <a:bodyPr wrap="square"/>
+                    <a:lstStyle/>
+                    <a:p>
+                      <a:r>
+                        <a:rPr sz="1200" b="0">
+                          <a:solidFill>
+                            <a:srgbClr val="0F172A"/>
+                          </a:solidFill>
+                          <a:latin typeface="Calibri"/>
+                        </a:rPr>
+                        <a:t>12</a:t>
+                      </a:r>
+                    </a:p>
+                  </a:txBody>
+                  <a:tcPr marL="73152" marR="73152" marT="36576" marB="36576" anchor="ctr">
+                    <a:solidFill>
+                      <a:srgbClr val="F8FAFC"/>
+                    </a:solidFill>
+                  </a:tcPr>
+                </a:tc>
+                <a:tc>
+                  <a:txBody>
+                    <a:bodyPr wrap="square"/>
+                    <a:lstStyle/>
+                    <a:p>
+                      <a:r>
+                        <a:rPr sz="1200" b="0">
+                          <a:solidFill>
+                            <a:srgbClr val="0F172A"/>
+                          </a:solidFill>
+                          <a:latin typeface="Calibri"/>
+                        </a:rPr>
+                        <a:t>medium</a:t>
+                      </a:r>
+                    </a:p>
+                  </a:txBody>
+                  <a:tcPr marL="73152" marR="73152" marT="36576" marB="36576" anchor="ctr">
+                    <a:solidFill>
+                      <a:srgbClr val="F8FAFC"/>
+                    </a:solidFill>
+                  </a:tcPr>
+                </a:tc>
+                <a:tc>
+                  <a:txBody>
+                    <a:bodyPr wrap="square"/>
+                    <a:lstStyle/>
+                    <a:p>
+                      <a:r>
+                        <a:rPr sz="1200" b="0">
+                          <a:solidFill>
+                            <a:srgbClr val="0F172A"/>
+                          </a:solidFill>
+                          <a:latin typeface="Calibri"/>
+                        </a:rPr>
+                        <a:t>GCS-001</a:t>
+                      </a:r>
+                    </a:p>
+                  </a:txBody>
+                  <a:tcPr marL="73152" marR="73152" marT="36576" marB="36576" anchor="ctr">
+                    <a:solidFill>
+                      <a:srgbClr val="F8FAFC"/>
+                    </a:solidFill>
+                  </a:tcPr>
+                </a:tc>
+                <a:tc>
+                  <a:txBody>
+                    <a:bodyPr wrap="square"/>
+                    <a:lstStyle/>
+                    <a:p>
+                      <a:r>
+                        <a:rPr sz="1200" b="0">
+                          <a:solidFill>
+                            <a:srgbClr val="0F172A"/>
+                          </a:solidFill>
+                          <a:latin typeface="Calibri"/>
+                        </a:rPr>
+                        <a:t>gs://exports/csv/</a:t>
+                      </a:r>
+                    </a:p>
+                  </a:txBody>
+                  <a:tcPr marL="73152" marR="73152" marT="36576" marB="36576" anchor="ctr">
+                    <a:solidFill>
+                      <a:srgbClr val="F8FAFC"/>
+                    </a:solidFill>
+                  </a:tcPr>
+                </a:tc>
+                <a:tc>
+                  <a:txBody>
+                    <a:bodyPr wrap="square"/>
+                    <a:lstStyle/>
+                    <a:p>
+                      <a:r>
+                        <a:rPr sz="1200" b="0">
+                          <a:solidFill>
+                            <a:srgbClr val="0F172A"/>
+                          </a:solidFill>
+                          <a:latin typeface="Calibri"/>
+                        </a:rPr>
+                        <a:t>Add a lifecycle rule and clear the backlog</a:t>
+                      </a:r>
+                    </a:p>
+                  </a:txBody>
+                  <a:tcPr marL="73152" marR="73152" marT="36576" marB="36576" anchor="ctr">
+                    <a:solidFill>
+                      <a:srgbClr val="F8FAFC"/>
+                    </a:solidFill>
+                  </a:tcPr>
+                </a:tc>
+                <a:tc>
+                  <a:txBody>
+                    <a:bodyPr wrap="square"/>
+                    <a:lstStyle/>
+                    <a:p>
+                      <a:r>
+                        <a:rPr sz="1200" b="0">
+                          <a:solidFill>
+                            <a:srgbClr val="0F172A"/>
+                          </a:solidFill>
+                          <a:latin typeface="Calibri"/>
+                        </a:rPr>
+                        <a:t>medium</a:t>
+                      </a:r>
+                    </a:p>
+                  </a:txBody>
+                  <a:tcPr marL="73152" marR="73152" marT="36576" marB="36576" anchor="ctr">
+                    <a:solidFill>
+                      <a:srgbClr val="F8FAFC"/>
+                    </a:solidFill>
+                  </a:tcPr>
+                </a:tc>
+              </a:tr>
+              <a:tr h="384048">
+                <a:tc>
+                  <a:txBody>
+                    <a:bodyPr wrap="square"/>
+                    <a:lstStyle/>
+                    <a:p>
+                      <a:r>
+                        <a:rPr sz="1200" b="0">
+                          <a:solidFill>
+                            <a:srgbClr val="0F172A"/>
+                          </a:solidFill>
+                          <a:latin typeface="Calibri"/>
+                        </a:rPr>
+                        <a:t>13</a:t>
+                      </a:r>
+                    </a:p>
+                  </a:txBody>
+                  <a:tcPr marL="73152" marR="73152" marT="36576" marB="36576" anchor="ctr">
+                    <a:solidFill>
+                      <a:srgbClr val="FFFFFF"/>
+                    </a:solidFill>
+                  </a:tcPr>
+                </a:tc>
+                <a:tc>
+                  <a:txBody>
+                    <a:bodyPr wrap="square"/>
+                    <a:lstStyle/>
+                    <a:p>
+                      <a:r>
+                        <a:rPr sz="1200" b="0">
+                          <a:solidFill>
+                            <a:srgbClr val="0F172A"/>
+                          </a:solidFill>
+                          <a:latin typeface="Calibri"/>
+                        </a:rPr>
+                        <a:t>low</a:t>
+                      </a:r>
+                    </a:p>
+                  </a:txBody>
+                  <a:tcPr marL="73152" marR="73152" marT="36576" marB="36576" anchor="ctr">
+                    <a:solidFill>
+                      <a:srgbClr val="FFFFFF"/>
+                    </a:solidFill>
+                  </a:tcPr>
+                </a:tc>
+                <a:tc>
+                  <a:txBody>
+                    <a:bodyPr wrap="square"/>
+                    <a:lstStyle/>
+                    <a:p>
+                      <a:r>
+                        <a:rPr sz="1200" b="0">
+                          <a:solidFill>
+                            <a:srgbClr val="0F172A"/>
+                          </a:solidFill>
+                          <a:latin typeface="Calibri"/>
+                        </a:rPr>
+                        <a:t>AWS-003</a:t>
+                      </a:r>
+                    </a:p>
+                  </a:txBody>
+                  <a:tcPr marL="73152" marR="73152" marT="36576" marB="36576" anchor="ctr">
+                    <a:solidFill>
+                      <a:srgbClr val="FFFFFF"/>
+                    </a:solidFill>
+                  </a:tcPr>
+                </a:tc>
+                <a:tc>
+                  <a:txBody>
+                    <a:bodyPr wrap="square"/>
+                    <a:lstStyle/>
+                    <a:p>
+                      <a:r>
+                        <a:rPr sz="1200" b="0">
+                          <a:solidFill>
+                            <a:srgbClr val="0F172A"/>
+                          </a:solidFill>
+                          <a:latin typeface="Calibri"/>
+                        </a:rPr>
+                        <a:t>redshift-reporting</a:t>
+                      </a:r>
+                    </a:p>
+                  </a:txBody>
+                  <a:tcPr marL="73152" marR="73152" marT="36576" marB="36576" anchor="ctr">
+                    <a:solidFill>
+                      <a:srgbClr val="FFFFFF"/>
+                    </a:solidFill>
+                  </a:tcPr>
+                </a:tc>
+                <a:tc>
+                  <a:txBody>
+                    <a:bodyPr wrap="square"/>
+                    <a:lstStyle/>
+                    <a:p>
+                      <a:r>
+                        <a:rPr sz="1200" b="0">
+                          <a:solidFill>
+                            <a:srgbClr val="0F172A"/>
+                          </a:solidFill>
+                          <a:latin typeface="Calibri"/>
+                        </a:rPr>
+                        <a:t>Confirm owner and dependencies before resizing</a:t>
+                      </a:r>
+                    </a:p>
+                  </a:txBody>
+                  <a:tcPr marL="73152" marR="73152" marT="36576" marB="36576" anchor="ctr">
+                    <a:solidFill>
+                      <a:srgbClr val="FFFFFF"/>
+                    </a:solidFill>
+                  </a:tcPr>
+                </a:tc>
+                <a:tc>
+                  <a:txBody>
+                    <a:bodyPr wrap="square"/>
+                    <a:lstStyle/>
+                    <a:p>
+                      <a:r>
+                        <a:rPr sz="1200" b="0">
+                          <a:solidFill>
+                            <a:srgbClr val="0F172A"/>
+                          </a:solidFill>
+                          <a:latin typeface="Calibri"/>
+                        </a:rPr>
+                        <a:t>low</a:t>
+                      </a:r>
+                    </a:p>
+                  </a:txBody>
+                  <a:tcPr marL="73152" marR="73152" marT="36576" marB="36576" anchor="ctr">
+                    <a:solidFill>
+                      <a:srgbClr val="FFFFFF"/>
+                    </a:solidFill>
+                  </a:tcPr>
+                </a:tc>
+              </a:tr>
+              <a:tr h="384048">
+                <a:tc>
+                  <a:txBody>
+                    <a:bodyPr wrap="square"/>
+                    <a:lstStyle/>
+                    <a:p>
+                      <a:r>
+                        <a:rPr sz="1200" b="0">
+                          <a:solidFill>
+                            <a:srgbClr val="0F172A"/>
+                          </a:solidFill>
+                          <a:latin typeface="Calibri"/>
+                        </a:rPr>
+                        <a:t>14</a:t>
+                      </a:r>
+                    </a:p>
+                  </a:txBody>
+                  <a:tcPr marL="73152" marR="73152" marT="36576" marB="36576" anchor="ctr">
+                    <a:solidFill>
+                      <a:srgbClr val="F8FAFC"/>
+                    </a:solidFill>
+                  </a:tcPr>
+                </a:tc>
+                <a:tc>
+                  <a:txBody>
+                    <a:bodyPr wrap="square"/>
+                    <a:lstStyle/>
+                    <a:p>
+                      <a:r>
+                        <a:rPr sz="1200" b="0">
+                          <a:solidFill>
+                            <a:srgbClr val="0F172A"/>
+                          </a:solidFill>
+                          <a:latin typeface="Calibri"/>
+                        </a:rPr>
+                        <a:t>low</a:t>
+                      </a:r>
+                    </a:p>
+                  </a:txBody>
+                  <a:tcPr marL="73152" marR="73152" marT="36576" marB="36576" anchor="ctr">
+                    <a:solidFill>
+                      <a:srgbClr val="F8FAFC"/>
+                    </a:solidFill>
+                  </a:tcPr>
+                </a:tc>
+                <a:tc>
+                  <a:txBody>
+                    <a:bodyPr wrap="square"/>
+                    <a:lstStyle/>
+                    <a:p>
+                      <a:r>
+                        <a:rPr sz="1200" b="0">
+                          <a:solidFill>
+                            <a:srgbClr val="0F172A"/>
+                          </a:solidFill>
+                          <a:latin typeface="Calibri"/>
+                        </a:rPr>
+                        <a:t>CMT-001</a:t>
+                      </a:r>
+                    </a:p>
+                  </a:txBody>
+                  <a:tcPr marL="73152" marR="73152" marT="36576" marB="36576" anchor="ctr">
+                    <a:solidFill>
+                      <a:srgbClr val="F8FAFC"/>
+                    </a:solidFill>
+                  </a:tcPr>
+                </a:tc>
+                <a:tc>
+                  <a:txBody>
+                    <a:bodyPr wrap="square"/>
+                    <a:lstStyle/>
+                    <a:p>
+                      <a:r>
+                        <a:rPr sz="1200" b="0">
+                          <a:solidFill>
+                            <a:srgbClr val="0F172A"/>
+                          </a:solidFill>
+                          <a:latin typeface="Calibri"/>
+                        </a:rPr>
+                        <a:t>AWS Glue</a:t>
+                      </a:r>
+                    </a:p>
+                  </a:txBody>
+                  <a:tcPr marL="73152" marR="73152" marT="36576" marB="36576" anchor="ctr">
+                    <a:solidFill>
+                      <a:srgbClr val="F8FAFC"/>
+                    </a:solidFill>
+                  </a:tcPr>
+                </a:tc>
+                <a:tc>
+                  <a:txBody>
+                    <a:bodyPr wrap="square"/>
+                    <a:lstStyle/>
+                    <a:p>
+                      <a:r>
+                        <a:rPr sz="1200" b="0">
+                          <a:solidFill>
+                            <a:srgbClr val="0F172A"/>
+                          </a:solidFill>
+                          <a:latin typeface="Calibri"/>
+                        </a:rPr>
+                        <a:t>Collect missing evidence before any commitment</a:t>
+                      </a:r>
+                    </a:p>
+                  </a:txBody>
+                  <a:tcPr marL="73152" marR="73152" marT="36576" marB="36576" anchor="ctr">
+                    <a:solidFill>
+                      <a:srgbClr val="F8FAFC"/>
+                    </a:solidFill>
+                  </a:tcPr>
+                </a:tc>
+                <a:tc>
+                  <a:txBody>
+                    <a:bodyPr wrap="square"/>
+                    <a:lstStyle/>
+                    <a:p>
+                      <a:r>
+                        <a:rPr sz="1200" b="0">
+                          <a:solidFill>
+                            <a:srgbClr val="0F172A"/>
+                          </a:solidFill>
+                          <a:latin typeface="Calibri"/>
+                        </a:rPr>
+                        <a:t>medium</a:t>
+                      </a:r>
+                    </a:p>
+                  </a:txBody>
+                  <a:tcPr marL="73152" marR="73152" marT="36576" marB="36576" anchor="ctr">
+                    <a:solidFill>
+                      <a:srgbClr val="F8FAFC"/>
+                    </a:solidFill>
+                  </a:tcPr>
+                </a:tc>
+              </a:tr>
+            </a:tbl>
+          </a:graphicData>
+        </a:graphic>
+      </p:graphicFrame>
+      <p:sp>
+        <p:nvSpPr>
+          <p:cNvPr id="5" name="Footer"/>
+          <p:cNvSpPr txBox="1"/>
+          <p:nvPr/>
+        </p:nvSpPr>
+        <p:spPr>
+          <a:xfrm>
+            <a:off x="548640" y="6400800"/>
+            <a:ext cx="11094415" cy="320040"/>
+          </a:xfrm>
+          <a:prstGeom prst="rect">
+            <a:avLst/>
+          </a:prstGeom>
+          <a:noFill/>
+        </p:spPr>
+        <p:txBody>
+          <a:bodyPr wrap="square" lIns="45720" rIns="45720" tIns="27432" bIns="27432">
+            <a:noAutofit/>
+          </a:bodyPr>
+          <a:lstStyle/>
+          <a:p>
+            <a:pPr>
+              <a:spcAft>
+                <a:spcPts val="450"/>
+              </a:spcAft>
+            </a:pPr>
+            <a:r>
+              <a:rPr sz="1000" b="0">
+                <a:solidFill>
+                  <a:srgbClr val="475569"/>
+                </a:solidFill>
+                <a:latin typeface="Calibri"/>
+              </a:rPr>
+              <a:t>Synthetic fixture data · demo-2026-09 · 5</a:t>
+            </a:r>
+          </a:p>
+        </p:txBody>
+      </p:sp>
+    </p:spTree>
+  </p:cSld>
+  <p:clrMapOvr>
+    <a:masterClrMapping/>
+  </p:clrMapOvr>
+</p:sld>
+</file>
+
+<file path=ppt/slides/slide6.xml><?xml version="1.0" encoding="utf-8"?>
+<p:sld xmlns:a="http://schemas.openxmlformats.org/drawingml/2006/main" xmlns:p="http://schemas.openxmlformats.org/presentationml/2006/main" xmlns:r="http://schemas.openxmlformats.org/officeDocument/2006/relationships">
+  <p:cSld name="risks-and-assumptions">
+    <p:bg>
+      <p:bgPr>
+        <a:solidFill>
+          <a:srgbClr val="FFFFFF"/>
+        </a:solidFill>
+        <a:effectLst/>
+      </p:bgPr>
+    </p:bg>
+    <p:spTree>
+      <p:nvGrpSpPr>
+        <p:cNvPr id="1" name=""/>
+        <p:cNvGrpSpPr/>
+        <p:nvPr/>
+      </p:nvGrpSpPr>
+      <p:grpSpPr/>
+      <p:sp>
+        <p:nvSpPr>
+          <p:cNvPr id="2" name="Title 1"/>
+          <p:cNvSpPr>
+            <a:spLocks noGrp="1"/>
+          </p:cNvSpPr>
+          <p:nvPr>
+            <p:ph type="title"/>
+          </p:nvPr>
+        </p:nvSpPr>
+        <p:spPr>
+          <a:xfrm>
+            <a:off x="548640" y="320040"/>
+            <a:ext cx="11094415" cy="731520"/>
+          </a:xfrm>
+        </p:spPr>
+        <p:txBody>
+          <a:bodyPr lIns="45720" wrap="square" anchor="ctr">
+            <a:noAutofit/>
+          </a:bodyPr>
+          <a:lstStyle/>
+          <a:p>
+            <a:pPr algn="l"/>
+            <a:r>
+              <a:rPr sz="2800" b="1">
+                <a:solidFill>
+                  <a:srgbClr val="0F172A"/>
+                </a:solidFill>
+                <a:latin typeface="Calibri"/>
+              </a:rPr>
+              <a:t>Risks and assumptions</a:t>
+            </a:r>
+          </a:p>
+        </p:txBody>
+      </p:sp>
+      <p:sp>
+        <p:nvSpPr>
+          <p:cNvPr id="3" name="Accent"/>
+          <p:cNvSpPr/>
+          <p:nvPr/>
+        </p:nvSpPr>
+        <p:spPr>
+          <a:xfrm>
+            <a:off x="548640" y="1078992"/>
+            <a:ext cx="1097280" cy="54864"/>
+          </a:xfrm>
+          <a:prstGeom prst="rect">
+            <a:avLst/>
+          </a:prstGeom>
+          <a:solidFill>
+            <a:srgbClr val="22D3EE"/>
+          </a:solidFill>
+          <a:ln>
+            <a:noFill/>
+          </a:ln>
+          <a:effectLst/>
+        </p:spPr>
+        <p:style>
+          <a:lnRef idx="1">
+            <a:schemeClr val="accent1"/>
+          </a:lnRef>
+          <a:fillRef idx="3">
+            <a:schemeClr val="accent1"/>
+          </a:fillRef>
+          <a:effectRef idx="2">
+            <a:schemeClr val="accent1"/>
+          </a:effectRef>
+          <a:fontRef idx="minor">
+            <a:schemeClr val="lt1"/>
+          </a:fontRef>
+        </p:style>
+        <p:txBody>
+          <a:bodyPr rtlCol="0" anchor="ctr"/>
+          <a:lstStyle/>
+          <a:p>
+            <a:pPr algn="ctr"/>
+          </a:p>
+        </p:txBody>
+      </p:sp>
       <p:sp>
         <p:nvSpPr>
           <p:cNvPr id="4" name="Assumptions panel"/>
@@ -8043,7 +8755,7 @@
                 </a:solidFill>
                 <a:latin typeface="Calibri"/>
               </a:rPr>
-              <a:t>Synthetic fixture data · demo-2026-09 · 5</a:t>
+              <a:t>Synthetic fixture data · demo-2026-09 · 6</a:t>
             </a:r>
           </a:p>
         </p:txBody>
@@ -8056,7 +8768,7 @@
 </p:sld>
 </file>
 
-<file path=ppt/slides/slide6.xml><?xml version="1.0" encoding="utf-8"?>
+<file path=ppt/slides/slide7.xml><?xml version="1.0" encoding="utf-8"?>
 <p:sld xmlns:a="http://schemas.openxmlformats.org/drawingml/2006/main" xmlns:p="http://schemas.openxmlformats.org/presentationml/2006/main" xmlns:r="http://schemas.openxmlformats.org/officeDocument/2006/relationships">
   <p:cSld name="evidence-appendix">
     <p:bg>
@@ -8104,7 +8816,7 @@
                 </a:solidFill>
                 <a:latin typeface="Calibri"/>
               </a:rPr>
-              <a:t>Evidence appendix (1 of 2)</a:t>
+              <a:t>Evidence appendix (1 of 3)</a:t>
             </a:r>
           </a:p>
         </p:txBody>
@@ -8863,7 +9575,7 @@
                           </a:solidFill>
                           <a:latin typeface="Calibri"/>
                         </a:rPr>
-                        <a:t>AWS-002</a:t>
+                        <a:t>BQ-006</a:t>
                       </a:r>
                     </a:p>
                   </a:txBody>
@@ -8885,7 +9597,7 @@
                           </a:solidFill>
                           <a:latin typeface="Calibri"/>
                         </a:rPr>
-                        <a:t>team=(untagged)</a:t>
+                        <a:t>ops.rate_control</a:t>
                       </a:r>
                     </a:p>
                   </a:txBody>
@@ -8907,7 +9619,7 @@
                           </a:solidFill>
                           <a:latin typeface="Calibri"/>
                         </a:rPr>
-                        <a:t>aws.tag_costs</a:t>
+                        <a:t>gcp.dml_tables</a:t>
                       </a:r>
                     </a:p>
                   </a:txBody>
@@ -8929,7 +9641,7 @@
                           </a:solidFill>
                           <a:latin typeface="Calibri"/>
                         </a:rPr>
-                        <a:t>USD 650 vs USD 300 baseline</a:t>
+                        <a:t>see findings.json</a:t>
                       </a:r>
                     </a:p>
                   </a:txBody>
@@ -8951,7 +9663,7 @@
                           </a:solidFill>
                           <a:latin typeface="Calibri"/>
                         </a:rPr>
-                        <a:t>Not estimated</a:t>
+                        <a:t>13,429.8</a:t>
                       </a:r>
                     </a:p>
                   </a:txBody>
@@ -8975,7 +9687,7 @@
                           </a:solidFill>
                           <a:latin typeface="Calibri"/>
                         </a:rPr>
-                        <a:t>BQ-002</a:t>
+                        <a:t>BQ-007</a:t>
                       </a:r>
                     </a:p>
                   </a:txBody>
@@ -8997,7 +9709,7 @@
                           </a:solidFill>
                           <a:latin typeface="Calibri"/>
                         </a:rPr>
-                        <a:t>fp-adhoc-cohort</a:t>
+                        <a:t>trusted.reports</a:t>
                       </a:r>
                     </a:p>
                   </a:txBody>
@@ -9019,7 +9731,7 @@
                           </a:solidFill>
                           <a:latin typeface="Calibri"/>
                         </a:rPr>
-                        <a:t>gcp.jobs</a:t>
+                        <a:t>gcp.table_rebuilds</a:t>
                       </a:r>
                     </a:p>
                   </a:txBody>
@@ -9041,7 +9753,7 @@
                           </a:solidFill>
                           <a:latin typeface="Calibri"/>
                         </a:rPr>
-                        <a:t>3 runs, 0.8 TB repeated</a:t>
+                        <a:t>see findings.json</a:t>
                       </a:r>
                     </a:p>
                   </a:txBody>
@@ -9063,7 +9775,7 @@
                           </a:solidFill>
                           <a:latin typeface="Calibri"/>
                         </a:rPr>
-                        <a:t>0.8 TB (upper bound)</a:t>
+                        <a:t>1.6</a:t>
                       </a:r>
                     </a:p>
                   </a:txBody>
@@ -9087,7 +9799,7 @@
                           </a:solidFill>
                           <a:latin typeface="Calibri"/>
                         </a:rPr>
-                        <a:t>BQ-004</a:t>
+                        <a:t>AWS-002</a:t>
                       </a:r>
                     </a:p>
                   </a:txBody>
@@ -9109,7 +9821,7 @@
                           </a:solidFill>
                           <a:latin typeface="Calibri"/>
                         </a:rPr>
-                        <a:t>fp-hourly-kpi-refresh</a:t>
+                        <a:t>team=(untagged)</a:t>
                       </a:r>
                     </a:p>
                   </a:txBody>
@@ -9131,7 +9843,7 @@
                           </a:solidFill>
                           <a:latin typeface="Calibri"/>
                         </a:rPr>
-                        <a:t>gcp.schedules</a:t>
+                        <a:t>aws.tag_costs</a:t>
                       </a:r>
                     </a:p>
                   </a:txBody>
@@ -9153,7 +9865,7 @@
                           </a:solidFill>
                           <a:latin typeface="Calibri"/>
                         </a:rPr>
-                        <a:t>6 runs/day; source changes 1/day</a:t>
+                        <a:t>USD 650 vs USD 300 baseline</a:t>
                       </a:r>
                     </a:p>
                   </a:txBody>
@@ -9175,7 +9887,7 @@
                           </a:solidFill>
                           <a:latin typeface="Calibri"/>
                         </a:rPr>
-                        <a:t>7.5 TB per 30 days</a:t>
+                        <a:t>Not estimated</a:t>
                       </a:r>
                     </a:p>
                   </a:txBody>
@@ -9199,7 +9911,7 @@
                           </a:solidFill>
                           <a:latin typeface="Calibri"/>
                         </a:rPr>
-                        <a:t>BQ-005</a:t>
+                        <a:t>BQ-002</a:t>
                       </a:r>
                     </a:p>
                   </a:txBody>
@@ -9221,7 +9933,7 @@
                           </a:solidFill>
                           <a:latin typeface="Calibri"/>
                         </a:rPr>
-                        <a:t>res-batch-etl</a:t>
+                        <a:t>fp-adhoc-cohort</a:t>
                       </a:r>
                     </a:p>
                   </a:txBody>
@@ -9243,7 +9955,7 @@
                           </a:solidFill>
                           <a:latin typeface="Calibri"/>
                         </a:rPr>
-                        <a:t>gcp.reservations</a:t>
+                        <a:t>gcp.jobs</a:t>
                       </a:r>
                     </a:p>
                   </a:txBody>
@@ -9265,7 +9977,7 @@
                           </a:solidFill>
                           <a:latin typeface="Calibri"/>
                         </a:rPr>
-                        <a:t>18% of 500 slots used</a:t>
+                        <a:t>3 runs, 0.8 TB repeated</a:t>
                       </a:r>
                     </a:p>
                   </a:txBody>
@@ -9287,7 +9999,7 @@
                           </a:solidFill>
                           <a:latin typeface="Calibri"/>
                         </a:rPr>
-                        <a:t>295,200 idle slot-hours</a:t>
+                        <a:t>0.8 TB (upper bound)</a:t>
                       </a:r>
                     </a:p>
                   </a:txBody>
@@ -9311,7 +10023,7 @@
                           </a:solidFill>
                           <a:latin typeface="Calibri"/>
                         </a:rPr>
-                        <a:t>AWS-003</a:t>
+                        <a:t>BQ-004</a:t>
                       </a:r>
                     </a:p>
                   </a:txBody>
@@ -9333,7 +10045,7 @@
                           </a:solidFill>
                           <a:latin typeface="Calibri"/>
                         </a:rPr>
-                        <a:t>redshift-reporting</a:t>
+                        <a:t>fp-hourly-kpi-refresh</a:t>
                       </a:r>
                     </a:p>
                   </a:txBody>
@@ -9355,7 +10067,7 @@
                           </a:solidFill>
                           <a:latin typeface="Calibri"/>
                         </a:rPr>
-                        <a:t>aws.resources</a:t>
+                        <a:t>gcp.schedules</a:t>
                       </a:r>
                     </a:p>
                   </a:txBody>
@@ -9377,7 +10089,7 @@
                           </a:solidFill>
                           <a:latin typeface="Calibri"/>
                         </a:rPr>
-                        <a:t>4% utilization over 30 days</a:t>
+                        <a:t>6 runs/day; source changes 1/day</a:t>
                       </a:r>
                     </a:p>
                   </a:txBody>
@@ -9399,7 +10111,7 @@
                           </a:solidFill>
                           <a:latin typeface="Calibri"/>
                         </a:rPr>
-                        <a:t>USD 2,112 per month</a:t>
+                        <a:t>7.5 TB per 30 days</a:t>
                       </a:r>
                     </a:p>
                   </a:txBody>
@@ -9423,7 +10135,7 @@
                           </a:solidFill>
                           <a:latin typeface="Calibri"/>
                         </a:rPr>
-                        <a:t>CMT-001</a:t>
+                        <a:t>BQ-005</a:t>
                       </a:r>
                     </a:p>
                   </a:txBody>
@@ -9445,7 +10157,7 @@
                           </a:solidFill>
                           <a:latin typeface="Calibri"/>
                         </a:rPr>
-                        <a:t>AWS Glue</a:t>
+                        <a:t>res-batch-etl</a:t>
                       </a:r>
                     </a:p>
                   </a:txBody>
@@ -9467,7 +10179,7 @@
                           </a:solidFill>
                           <a:latin typeface="Calibri"/>
                         </a:rPr>
-                        <a:t>aws.commitments</a:t>
+                        <a:t>gcp.reservations</a:t>
                       </a:r>
                     </a:p>
                   </a:txBody>
@@ -9489,7 +10201,7 @@
                           </a:solidFill>
                           <a:latin typeface="Calibri"/>
                         </a:rPr>
-                        <a:t>CV 0.02, coverage 0%</a:t>
+                        <a:t>18% of 500 slots used</a:t>
                       </a:r>
                     </a:p>
                   </a:txBody>
@@ -9511,7 +10223,7 @@
                           </a:solidFill>
                           <a:latin typeface="Calibri"/>
                         </a:rPr>
-                        <a:t>Not estimated</a:t>
+                        <a:t>295,200 idle slot-hours</a:t>
                       </a:r>
                     </a:p>
                   </a:txBody>
@@ -9560,7 +10272,7 @@
                 </a:solidFill>
                 <a:latin typeface="Calibri"/>
               </a:rPr>
-              <a:t>Synthetic fixture data · demo-2026-09 · 6</a:t>
+              <a:t>Synthetic fixture data · demo-2026-09 · 7</a:t>
             </a:r>
           </a:p>
         </p:txBody>
@@ -9573,7 +10285,7 @@
 </p:sld>
 </file>
 
-<file path=ppt/slides/slide7.xml><?xml version="1.0" encoding="utf-8"?>
+<file path=ppt/slides/slide8.xml><?xml version="1.0" encoding="utf-8"?>
 <p:sld xmlns:a="http://schemas.openxmlformats.org/drawingml/2006/main" xmlns:p="http://schemas.openxmlformats.org/presentationml/2006/main" xmlns:r="http://schemas.openxmlformats.org/officeDocument/2006/relationships">
   <p:cSld name="evidence-appendix">
     <p:bg>
@@ -9621,7 +10333,7 @@
                 </a:solidFill>
                 <a:latin typeface="Calibri"/>
               </a:rPr>
-              <a:t>Evidence appendix (2 of 2)</a:t>
+              <a:t>Evidence appendix (2 of 3)</a:t>
             </a:r>
           </a:p>
         </p:txBody>
@@ -9670,6 +10382,627 @@
           </a:p>
         </p:txBody>
       </p:sp>
+      <p:graphicFrame>
+        <p:nvGraphicFramePr>
+          <p:cNvPr id="4" name="Table"/>
+          <p:cNvGraphicFramePr>
+            <a:graphicFrameLocks noGrp="1"/>
+          </p:cNvGraphicFramePr>
+          <p:nvPr/>
+        </p:nvGraphicFramePr>
+        <p:xfrm>
+          <a:off x="548640" y="1325880"/>
+          <a:ext cx="11064240" cy="1536192"/>
+        </p:xfrm>
+        <a:graphic>
+          <a:graphicData uri="http://schemas.openxmlformats.org/drawingml/2006/table">
+            <a:tbl>
+              <a:tblPr firstRow="1" bandRow="1">
+                <a:tableStyleId>{5C22544A-7EE6-4342-B048-85BDC9FD1C3A}</a:tableStyleId>
+              </a:tblPr>
+              <a:tblGrid>
+                <a:gridCol w="914400"/>
+                <a:gridCol w="2743200"/>
+                <a:gridCol w="1737360"/>
+                <a:gridCol w="3383280"/>
+                <a:gridCol w="2286000"/>
+              </a:tblGrid>
+              <a:tr h="384048">
+                <a:tc>
+                  <a:txBody>
+                    <a:bodyPr wrap="square"/>
+                    <a:lstStyle/>
+                    <a:p>
+                      <a:r>
+                        <a:rPr sz="1200" b="1">
+                          <a:solidFill>
+                            <a:srgbClr val="FFFFFF"/>
+                          </a:solidFill>
+                          <a:latin typeface="Calibri"/>
+                        </a:rPr>
+                        <a:t>Rule</a:t>
+                      </a:r>
+                    </a:p>
+                  </a:txBody>
+                  <a:tcPr marL="73152" marR="73152" marT="36576" marB="36576" anchor="ctr">
+                    <a:solidFill>
+                      <a:srgbClr val="0F172A"/>
+                    </a:solidFill>
+                  </a:tcPr>
+                </a:tc>
+                <a:tc>
+                  <a:txBody>
+                    <a:bodyPr wrap="square"/>
+                    <a:lstStyle/>
+                    <a:p>
+                      <a:r>
+                        <a:rPr sz="1200" b="1">
+                          <a:solidFill>
+                            <a:srgbClr val="FFFFFF"/>
+                          </a:solidFill>
+                          <a:latin typeface="Calibri"/>
+                        </a:rPr>
+                        <a:t>Subject</a:t>
+                      </a:r>
+                    </a:p>
+                  </a:txBody>
+                  <a:tcPr marL="73152" marR="73152" marT="36576" marB="36576" anchor="ctr">
+                    <a:solidFill>
+                      <a:srgbClr val="0F172A"/>
+                    </a:solidFill>
+                  </a:tcPr>
+                </a:tc>
+                <a:tc>
+                  <a:txBody>
+                    <a:bodyPr wrap="square"/>
+                    <a:lstStyle/>
+                    <a:p>
+                      <a:r>
+                        <a:rPr sz="1200" b="1">
+                          <a:solidFill>
+                            <a:srgbClr val="FFFFFF"/>
+                          </a:solidFill>
+                          <a:latin typeface="Calibri"/>
+                        </a:rPr>
+                        <a:t>Evidence source</a:t>
+                      </a:r>
+                    </a:p>
+                  </a:txBody>
+                  <a:tcPr marL="73152" marR="73152" marT="36576" marB="36576" anchor="ctr">
+                    <a:solidFill>
+                      <a:srgbClr val="0F172A"/>
+                    </a:solidFill>
+                  </a:tcPr>
+                </a:tc>
+                <a:tc>
+                  <a:txBody>
+                    <a:bodyPr wrap="square"/>
+                    <a:lstStyle/>
+                    <a:p>
+                      <a:r>
+                        <a:rPr sz="1200" b="1">
+                          <a:solidFill>
+                            <a:srgbClr val="FFFFFF"/>
+                          </a:solidFill>
+                          <a:latin typeface="Calibri"/>
+                        </a:rPr>
+                        <a:t>Observed metric</a:t>
+                      </a:r>
+                    </a:p>
+                  </a:txBody>
+                  <a:tcPr marL="73152" marR="73152" marT="36576" marB="36576" anchor="ctr">
+                    <a:solidFill>
+                      <a:srgbClr val="0F172A"/>
+                    </a:solidFill>
+                  </a:tcPr>
+                </a:tc>
+                <a:tc>
+                  <a:txBody>
+                    <a:bodyPr wrap="square"/>
+                    <a:lstStyle/>
+                    <a:p>
+                      <a:r>
+                        <a:rPr sz="1200" b="1">
+                          <a:solidFill>
+                            <a:srgbClr val="FFFFFF"/>
+                          </a:solidFill>
+                          <a:latin typeface="Calibri"/>
+                        </a:rPr>
+                        <a:t>Estimate</a:t>
+                      </a:r>
+                    </a:p>
+                  </a:txBody>
+                  <a:tcPr marL="73152" marR="73152" marT="36576" marB="36576" anchor="ctr">
+                    <a:solidFill>
+                      <a:srgbClr val="0F172A"/>
+                    </a:solidFill>
+                  </a:tcPr>
+                </a:tc>
+              </a:tr>
+              <a:tr h="384048">
+                <a:tc>
+                  <a:txBody>
+                    <a:bodyPr wrap="square"/>
+                    <a:lstStyle/>
+                    <a:p>
+                      <a:r>
+                        <a:rPr sz="1200" b="0">
+                          <a:solidFill>
+                            <a:srgbClr val="0F172A"/>
+                          </a:solidFill>
+                          <a:latin typeface="Calibri"/>
+                        </a:rPr>
+                        <a:t>GCS-001</a:t>
+                      </a:r>
+                    </a:p>
+                  </a:txBody>
+                  <a:tcPr marL="73152" marR="73152" marT="36576" marB="36576" anchor="ctr">
+                    <a:solidFill>
+                      <a:srgbClr val="F8FAFC"/>
+                    </a:solidFill>
+                  </a:tcPr>
+                </a:tc>
+                <a:tc>
+                  <a:txBody>
+                    <a:bodyPr wrap="square"/>
+                    <a:lstStyle/>
+                    <a:p>
+                      <a:r>
+                        <a:rPr sz="1200" b="0">
+                          <a:solidFill>
+                            <a:srgbClr val="0F172A"/>
+                          </a:solidFill>
+                          <a:latin typeface="Calibri"/>
+                        </a:rPr>
+                        <a:t>gs://exports/csv/</a:t>
+                      </a:r>
+                    </a:p>
+                  </a:txBody>
+                  <a:tcPr marL="73152" marR="73152" marT="36576" marB="36576" anchor="ctr">
+                    <a:solidFill>
+                      <a:srgbClr val="F8FAFC"/>
+                    </a:solidFill>
+                  </a:tcPr>
+                </a:tc>
+                <a:tc>
+                  <a:txBody>
+                    <a:bodyPr wrap="square"/>
+                    <a:lstStyle/>
+                    <a:p>
+                      <a:r>
+                        <a:rPr sz="1200" b="0">
+                          <a:solidFill>
+                            <a:srgbClr val="0F172A"/>
+                          </a:solidFill>
+                          <a:latin typeface="Calibri"/>
+                        </a:rPr>
+                        <a:t>gcp.gcs_prefixes</a:t>
+                      </a:r>
+                    </a:p>
+                  </a:txBody>
+                  <a:tcPr marL="73152" marR="73152" marT="36576" marB="36576" anchor="ctr">
+                    <a:solidFill>
+                      <a:srgbClr val="F8FAFC"/>
+                    </a:solidFill>
+                  </a:tcPr>
+                </a:tc>
+                <a:tc>
+                  <a:txBody>
+                    <a:bodyPr wrap="square"/>
+                    <a:lstStyle/>
+                    <a:p>
+                      <a:r>
+                        <a:rPr sz="1200" b="0">
+                          <a:solidFill>
+                            <a:srgbClr val="0F172A"/>
+                          </a:solidFill>
+                          <a:latin typeface="Calibri"/>
+                        </a:rPr>
+                        <a:t>see findings.json</a:t>
+                      </a:r>
+                    </a:p>
+                  </a:txBody>
+                  <a:tcPr marL="73152" marR="73152" marT="36576" marB="36576" anchor="ctr">
+                    <a:solidFill>
+                      <a:srgbClr val="F8FAFC"/>
+                    </a:solidFill>
+                  </a:tcPr>
+                </a:tc>
+                <a:tc>
+                  <a:txBody>
+                    <a:bodyPr wrap="square"/>
+                    <a:lstStyle/>
+                    <a:p>
+                      <a:r>
+                        <a:rPr sz="1200" b="0">
+                          <a:solidFill>
+                            <a:srgbClr val="0F172A"/>
+                          </a:solidFill>
+                          <a:latin typeface="Calibri"/>
+                        </a:rPr>
+                        <a:t>7,088.1</a:t>
+                      </a:r>
+                    </a:p>
+                  </a:txBody>
+                  <a:tcPr marL="73152" marR="73152" marT="36576" marB="36576" anchor="ctr">
+                    <a:solidFill>
+                      <a:srgbClr val="F8FAFC"/>
+                    </a:solidFill>
+                  </a:tcPr>
+                </a:tc>
+              </a:tr>
+              <a:tr h="384048">
+                <a:tc>
+                  <a:txBody>
+                    <a:bodyPr wrap="square"/>
+                    <a:lstStyle/>
+                    <a:p>
+                      <a:r>
+                        <a:rPr sz="1200" b="0">
+                          <a:solidFill>
+                            <a:srgbClr val="0F172A"/>
+                          </a:solidFill>
+                          <a:latin typeface="Calibri"/>
+                        </a:rPr>
+                        <a:t>AWS-003</a:t>
+                      </a:r>
+                    </a:p>
+                  </a:txBody>
+                  <a:tcPr marL="73152" marR="73152" marT="36576" marB="36576" anchor="ctr">
+                    <a:solidFill>
+                      <a:srgbClr val="FFFFFF"/>
+                    </a:solidFill>
+                  </a:tcPr>
+                </a:tc>
+                <a:tc>
+                  <a:txBody>
+                    <a:bodyPr wrap="square"/>
+                    <a:lstStyle/>
+                    <a:p>
+                      <a:r>
+                        <a:rPr sz="1200" b="0">
+                          <a:solidFill>
+                            <a:srgbClr val="0F172A"/>
+                          </a:solidFill>
+                          <a:latin typeface="Calibri"/>
+                        </a:rPr>
+                        <a:t>redshift-reporting</a:t>
+                      </a:r>
+                    </a:p>
+                  </a:txBody>
+                  <a:tcPr marL="73152" marR="73152" marT="36576" marB="36576" anchor="ctr">
+                    <a:solidFill>
+                      <a:srgbClr val="FFFFFF"/>
+                    </a:solidFill>
+                  </a:tcPr>
+                </a:tc>
+                <a:tc>
+                  <a:txBody>
+                    <a:bodyPr wrap="square"/>
+                    <a:lstStyle/>
+                    <a:p>
+                      <a:r>
+                        <a:rPr sz="1200" b="0">
+                          <a:solidFill>
+                            <a:srgbClr val="0F172A"/>
+                          </a:solidFill>
+                          <a:latin typeface="Calibri"/>
+                        </a:rPr>
+                        <a:t>aws.resources</a:t>
+                      </a:r>
+                    </a:p>
+                  </a:txBody>
+                  <a:tcPr marL="73152" marR="73152" marT="36576" marB="36576" anchor="ctr">
+                    <a:solidFill>
+                      <a:srgbClr val="FFFFFF"/>
+                    </a:solidFill>
+                  </a:tcPr>
+                </a:tc>
+                <a:tc>
+                  <a:txBody>
+                    <a:bodyPr wrap="square"/>
+                    <a:lstStyle/>
+                    <a:p>
+                      <a:r>
+                        <a:rPr sz="1200" b="0">
+                          <a:solidFill>
+                            <a:srgbClr val="0F172A"/>
+                          </a:solidFill>
+                          <a:latin typeface="Calibri"/>
+                        </a:rPr>
+                        <a:t>4% utilization over 30 days</a:t>
+                      </a:r>
+                    </a:p>
+                  </a:txBody>
+                  <a:tcPr marL="73152" marR="73152" marT="36576" marB="36576" anchor="ctr">
+                    <a:solidFill>
+                      <a:srgbClr val="FFFFFF"/>
+                    </a:solidFill>
+                  </a:tcPr>
+                </a:tc>
+                <a:tc>
+                  <a:txBody>
+                    <a:bodyPr wrap="square"/>
+                    <a:lstStyle/>
+                    <a:p>
+                      <a:r>
+                        <a:rPr sz="1200" b="0">
+                          <a:solidFill>
+                            <a:srgbClr val="0F172A"/>
+                          </a:solidFill>
+                          <a:latin typeface="Calibri"/>
+                        </a:rPr>
+                        <a:t>USD 2,112 per month</a:t>
+                      </a:r>
+                    </a:p>
+                  </a:txBody>
+                  <a:tcPr marL="73152" marR="73152" marT="36576" marB="36576" anchor="ctr">
+                    <a:solidFill>
+                      <a:srgbClr val="FFFFFF"/>
+                    </a:solidFill>
+                  </a:tcPr>
+                </a:tc>
+              </a:tr>
+              <a:tr h="384048">
+                <a:tc>
+                  <a:txBody>
+                    <a:bodyPr wrap="square"/>
+                    <a:lstStyle/>
+                    <a:p>
+                      <a:r>
+                        <a:rPr sz="1200" b="0">
+                          <a:solidFill>
+                            <a:srgbClr val="0F172A"/>
+                          </a:solidFill>
+                          <a:latin typeface="Calibri"/>
+                        </a:rPr>
+                        <a:t>CMT-001</a:t>
+                      </a:r>
+                    </a:p>
+                  </a:txBody>
+                  <a:tcPr marL="73152" marR="73152" marT="36576" marB="36576" anchor="ctr">
+                    <a:solidFill>
+                      <a:srgbClr val="F8FAFC"/>
+                    </a:solidFill>
+                  </a:tcPr>
+                </a:tc>
+                <a:tc>
+                  <a:txBody>
+                    <a:bodyPr wrap="square"/>
+                    <a:lstStyle/>
+                    <a:p>
+                      <a:r>
+                        <a:rPr sz="1200" b="0">
+                          <a:solidFill>
+                            <a:srgbClr val="0F172A"/>
+                          </a:solidFill>
+                          <a:latin typeface="Calibri"/>
+                        </a:rPr>
+                        <a:t>AWS Glue</a:t>
+                      </a:r>
+                    </a:p>
+                  </a:txBody>
+                  <a:tcPr marL="73152" marR="73152" marT="36576" marB="36576" anchor="ctr">
+                    <a:solidFill>
+                      <a:srgbClr val="F8FAFC"/>
+                    </a:solidFill>
+                  </a:tcPr>
+                </a:tc>
+                <a:tc>
+                  <a:txBody>
+                    <a:bodyPr wrap="square"/>
+                    <a:lstStyle/>
+                    <a:p>
+                      <a:r>
+                        <a:rPr sz="1200" b="0">
+                          <a:solidFill>
+                            <a:srgbClr val="0F172A"/>
+                          </a:solidFill>
+                          <a:latin typeface="Calibri"/>
+                        </a:rPr>
+                        <a:t>aws.commitments</a:t>
+                      </a:r>
+                    </a:p>
+                  </a:txBody>
+                  <a:tcPr marL="73152" marR="73152" marT="36576" marB="36576" anchor="ctr">
+                    <a:solidFill>
+                      <a:srgbClr val="F8FAFC"/>
+                    </a:solidFill>
+                  </a:tcPr>
+                </a:tc>
+                <a:tc>
+                  <a:txBody>
+                    <a:bodyPr wrap="square"/>
+                    <a:lstStyle/>
+                    <a:p>
+                      <a:r>
+                        <a:rPr sz="1200" b="0">
+                          <a:solidFill>
+                            <a:srgbClr val="0F172A"/>
+                          </a:solidFill>
+                          <a:latin typeface="Calibri"/>
+                        </a:rPr>
+                        <a:t>CV 0.02, coverage 0%</a:t>
+                      </a:r>
+                    </a:p>
+                  </a:txBody>
+                  <a:tcPr marL="73152" marR="73152" marT="36576" marB="36576" anchor="ctr">
+                    <a:solidFill>
+                      <a:srgbClr val="F8FAFC"/>
+                    </a:solidFill>
+                  </a:tcPr>
+                </a:tc>
+                <a:tc>
+                  <a:txBody>
+                    <a:bodyPr wrap="square"/>
+                    <a:lstStyle/>
+                    <a:p>
+                      <a:r>
+                        <a:rPr sz="1200" b="0">
+                          <a:solidFill>
+                            <a:srgbClr val="0F172A"/>
+                          </a:solidFill>
+                          <a:latin typeface="Calibri"/>
+                        </a:rPr>
+                        <a:t>Not estimated</a:t>
+                      </a:r>
+                    </a:p>
+                  </a:txBody>
+                  <a:tcPr marL="73152" marR="73152" marT="36576" marB="36576" anchor="ctr">
+                    <a:solidFill>
+                      <a:srgbClr val="F8FAFC"/>
+                    </a:solidFill>
+                  </a:tcPr>
+                </a:tc>
+              </a:tr>
+            </a:tbl>
+          </a:graphicData>
+        </a:graphic>
+      </p:graphicFrame>
+      <p:sp>
+        <p:nvSpPr>
+          <p:cNvPr id="5" name="Footer"/>
+          <p:cNvSpPr txBox="1"/>
+          <p:nvPr/>
+        </p:nvSpPr>
+        <p:spPr>
+          <a:xfrm>
+            <a:off x="548640" y="6400800"/>
+            <a:ext cx="11094415" cy="320040"/>
+          </a:xfrm>
+          <a:prstGeom prst="rect">
+            <a:avLst/>
+          </a:prstGeom>
+          <a:noFill/>
+        </p:spPr>
+        <p:txBody>
+          <a:bodyPr wrap="square" lIns="45720" rIns="45720" tIns="27432" bIns="27432">
+            <a:noAutofit/>
+          </a:bodyPr>
+          <a:lstStyle/>
+          <a:p>
+            <a:pPr>
+              <a:spcAft>
+                <a:spcPts val="450"/>
+              </a:spcAft>
+            </a:pPr>
+            <a:r>
+              <a:rPr sz="1000" b="0">
+                <a:solidFill>
+                  <a:srgbClr val="475569"/>
+                </a:solidFill>
+                <a:latin typeface="Calibri"/>
+              </a:rPr>
+              <a:t>Synthetic fixture data · demo-2026-09 · 8</a:t>
+            </a:r>
+          </a:p>
+        </p:txBody>
+      </p:sp>
+    </p:spTree>
+  </p:cSld>
+  <p:clrMapOvr>
+    <a:masterClrMapping/>
+  </p:clrMapOvr>
+</p:sld>
+</file>
+
+<file path=ppt/slides/slide9.xml><?xml version="1.0" encoding="utf-8"?>
+<p:sld xmlns:a="http://schemas.openxmlformats.org/drawingml/2006/main" xmlns:p="http://schemas.openxmlformats.org/presentationml/2006/main" xmlns:r="http://schemas.openxmlformats.org/officeDocument/2006/relationships">
+  <p:cSld name="evidence-appendix">
+    <p:bg>
+      <p:bgPr>
+        <a:solidFill>
+          <a:srgbClr val="FFFFFF"/>
+        </a:solidFill>
+        <a:effectLst/>
+      </p:bgPr>
+    </p:bg>
+    <p:spTree>
+      <p:nvGrpSpPr>
+        <p:cNvPr id="1" name=""/>
+        <p:cNvGrpSpPr/>
+        <p:nvPr/>
+      </p:nvGrpSpPr>
+      <p:grpSpPr/>
+      <p:sp>
+        <p:nvSpPr>
+          <p:cNvPr id="2" name="Title 1"/>
+          <p:cNvSpPr>
+            <a:spLocks noGrp="1"/>
+          </p:cNvSpPr>
+          <p:nvPr>
+            <p:ph type="title"/>
+          </p:nvPr>
+        </p:nvSpPr>
+        <p:spPr>
+          <a:xfrm>
+            <a:off x="548640" y="320040"/>
+            <a:ext cx="11094415" cy="731520"/>
+          </a:xfrm>
+        </p:spPr>
+        <p:txBody>
+          <a:bodyPr lIns="45720" wrap="square" anchor="ctr">
+            <a:noAutofit/>
+          </a:bodyPr>
+          <a:lstStyle/>
+          <a:p>
+            <a:pPr algn="l"/>
+            <a:r>
+              <a:rPr sz="2800" b="1">
+                <a:solidFill>
+                  <a:srgbClr val="0F172A"/>
+                </a:solidFill>
+                <a:latin typeface="Calibri"/>
+              </a:rPr>
+              <a:t>Evidence appendix (3 of 3)</a:t>
+            </a:r>
+          </a:p>
+        </p:txBody>
+      </p:sp>
+      <p:sp>
+        <p:nvSpPr>
+          <p:cNvPr id="3" name="Accent"/>
+          <p:cNvSpPr/>
+          <p:nvPr/>
+        </p:nvSpPr>
+        <p:spPr>
+          <a:xfrm>
+            <a:off x="548640" y="1078992"/>
+            <a:ext cx="1097280" cy="54864"/>
+          </a:xfrm>
+          <a:prstGeom prst="rect">
+            <a:avLst/>
+          </a:prstGeom>
+          <a:solidFill>
+            <a:srgbClr val="22D3EE"/>
+          </a:solidFill>
+          <a:ln>
+            <a:noFill/>
+          </a:ln>
+          <a:effectLst/>
+        </p:spPr>
+        <p:style>
+          <a:lnRef idx="1">
+            <a:schemeClr val="accent1"/>
+          </a:lnRef>
+          <a:fillRef idx="3">
+            <a:schemeClr val="accent1"/>
+          </a:fillRef>
+          <a:effectRef idx="2">
+            <a:schemeClr val="accent1"/>
+          </a:effectRef>
+          <a:fontRef idx="minor">
+            <a:schemeClr val="lt1"/>
+          </a:fontRef>
+        </p:style>
+        <p:txBody>
+          <a:bodyPr rtlCol="0" anchor="ctr"/>
+          <a:lstStyle/>
+          <a:p>
+            <a:pPr algn="ctr"/>
+          </a:p>
+        </p:txBody>
+      </p:sp>
       <p:sp>
         <p:nvSpPr>
           <p:cNvPr id="4" name="Reproduction"/>
@@ -9720,7 +11053,7 @@
                 </a:solidFill>
                 <a:latin typeface="Calibri"/>
               </a:rPr>
-              <a:t>findings.json SHA-256: e4ca61ca9a634f52c2fcde3dc20538e0879a59d15bede9601869f7cdbc8c014f</a:t>
+              <a:t>findings.json SHA-256: 31b9eb6e4e3f2678456bc916d09a8bd06695ebcbdaf82ff85db3357a468dc29a</a:t>
             </a:r>
           </a:p>
           <a:p>
@@ -9807,7 +11140,7 @@
                 </a:solidFill>
                 <a:latin typeface="Calibri"/>
               </a:rPr>
-              <a:t>Synthetic fixture data · demo-2026-09 · 7</a:t>
+              <a:t>Synthetic fixture data · demo-2026-09 · 9</a:t>
             </a:r>
           </a:p>
         </p:txBody>

</xml_diff>